<commit_message>
Add settings and avatars
</commit_message>
<xml_diff>
--- a/Prezentacja-zalozen.pptx
+++ b/Prezentacja-zalozen.pptx
@@ -265,7 +265,7 @@
           <a:p>
             <a:fld id="{E0E85077-6AEA-4ED0-AE91-480E49AAB448}" type="datetimeFigureOut">
               <a:rPr lang="pl-PL" smtClean="0"/>
-              <a:t>18.05.2026</a:t>
+              <a:t>8.06.2026</a:t>
             </a:fld>
             <a:endParaRPr lang="pl-PL"/>
           </a:p>
@@ -463,7 +463,7 @@
           <a:p>
             <a:fld id="{E0E85077-6AEA-4ED0-AE91-480E49AAB448}" type="datetimeFigureOut">
               <a:rPr lang="pl-PL" smtClean="0"/>
-              <a:t>18.05.2026</a:t>
+              <a:t>8.06.2026</a:t>
             </a:fld>
             <a:endParaRPr lang="pl-PL"/>
           </a:p>
@@ -671,7 +671,7 @@
           <a:p>
             <a:fld id="{E0E85077-6AEA-4ED0-AE91-480E49AAB448}" type="datetimeFigureOut">
               <a:rPr lang="pl-PL" smtClean="0"/>
-              <a:t>18.05.2026</a:t>
+              <a:t>8.06.2026</a:t>
             </a:fld>
             <a:endParaRPr lang="pl-PL"/>
           </a:p>
@@ -869,7 +869,7 @@
           <a:p>
             <a:fld id="{E0E85077-6AEA-4ED0-AE91-480E49AAB448}" type="datetimeFigureOut">
               <a:rPr lang="pl-PL" smtClean="0"/>
-              <a:t>18.05.2026</a:t>
+              <a:t>8.06.2026</a:t>
             </a:fld>
             <a:endParaRPr lang="pl-PL"/>
           </a:p>
@@ -1144,7 +1144,7 @@
           <a:p>
             <a:fld id="{E0E85077-6AEA-4ED0-AE91-480E49AAB448}" type="datetimeFigureOut">
               <a:rPr lang="pl-PL" smtClean="0"/>
-              <a:t>18.05.2026</a:t>
+              <a:t>8.06.2026</a:t>
             </a:fld>
             <a:endParaRPr lang="pl-PL"/>
           </a:p>
@@ -1409,7 +1409,7 @@
           <a:p>
             <a:fld id="{E0E85077-6AEA-4ED0-AE91-480E49AAB448}" type="datetimeFigureOut">
               <a:rPr lang="pl-PL" smtClean="0"/>
-              <a:t>18.05.2026</a:t>
+              <a:t>8.06.2026</a:t>
             </a:fld>
             <a:endParaRPr lang="pl-PL"/>
           </a:p>
@@ -1821,7 +1821,7 @@
           <a:p>
             <a:fld id="{E0E85077-6AEA-4ED0-AE91-480E49AAB448}" type="datetimeFigureOut">
               <a:rPr lang="pl-PL" smtClean="0"/>
-              <a:t>18.05.2026</a:t>
+              <a:t>8.06.2026</a:t>
             </a:fld>
             <a:endParaRPr lang="pl-PL"/>
           </a:p>
@@ -1962,7 +1962,7 @@
           <a:p>
             <a:fld id="{E0E85077-6AEA-4ED0-AE91-480E49AAB448}" type="datetimeFigureOut">
               <a:rPr lang="pl-PL" smtClean="0"/>
-              <a:t>18.05.2026</a:t>
+              <a:t>8.06.2026</a:t>
             </a:fld>
             <a:endParaRPr lang="pl-PL"/>
           </a:p>
@@ -2075,7 +2075,7 @@
           <a:p>
             <a:fld id="{E0E85077-6AEA-4ED0-AE91-480E49AAB448}" type="datetimeFigureOut">
               <a:rPr lang="pl-PL" smtClean="0"/>
-              <a:t>18.05.2026</a:t>
+              <a:t>8.06.2026</a:t>
             </a:fld>
             <a:endParaRPr lang="pl-PL"/>
           </a:p>
@@ -2386,7 +2386,7 @@
           <a:p>
             <a:fld id="{E0E85077-6AEA-4ED0-AE91-480E49AAB448}" type="datetimeFigureOut">
               <a:rPr lang="pl-PL" smtClean="0"/>
-              <a:t>18.05.2026</a:t>
+              <a:t>8.06.2026</a:t>
             </a:fld>
             <a:endParaRPr lang="pl-PL"/>
           </a:p>
@@ -2674,7 +2674,7 @@
           <a:p>
             <a:fld id="{E0E85077-6AEA-4ED0-AE91-480E49AAB448}" type="datetimeFigureOut">
               <a:rPr lang="pl-PL" smtClean="0"/>
-              <a:t>18.05.2026</a:t>
+              <a:t>8.06.2026</a:t>
             </a:fld>
             <a:endParaRPr lang="pl-PL"/>
           </a:p>
@@ -2915,7 +2915,7 @@
           <a:p>
             <a:fld id="{E0E85077-6AEA-4ED0-AE91-480E49AAB448}" type="datetimeFigureOut">
               <a:rPr lang="pl-PL" smtClean="0"/>
-              <a:t>18.05.2026</a:t>
+              <a:t>8.06.2026</a:t>
             </a:fld>
             <a:endParaRPr lang="pl-PL"/>
           </a:p>
@@ -3589,7 +3589,11 @@
           </a:p>
           <a:p>
             <a:r>
-              <a:rPr lang="pl-PL" dirty="0"/>
+              <a:rPr lang="pl-PL" dirty="0">
+                <a:highlight>
+                  <a:srgbClr val="00FF00"/>
+                </a:highlight>
+              </a:rPr>
               <a:t>Analityka – podsumowania tygodniowe i miesięczne oraz porównanie wydatków z założonym limitem.</a:t>
             </a:r>
           </a:p>
@@ -3754,7 +3758,11 @@
           <a:lstStyle/>
           <a:p>
             <a:r>
-              <a:rPr lang="pl-PL" dirty="0"/>
+              <a:rPr lang="pl-PL" dirty="0">
+                <a:highlight>
+                  <a:srgbClr val="00FF00"/>
+                </a:highlight>
+              </a:rPr>
               <a:t>Skanowanie paragonów</a:t>
             </a:r>
           </a:p>
@@ -3903,7 +3911,11 @@
           </a:p>
           <a:p>
             <a:r>
-              <a:rPr lang="pl-PL" dirty="0"/>
+              <a:rPr lang="pl-PL" dirty="0">
+                <a:highlight>
+                  <a:srgbClr val="00FF00"/>
+                </a:highlight>
+              </a:rPr>
               <a:t>Strona główna z podsumowaniem</a:t>
             </a:r>
           </a:p>
@@ -3933,7 +3945,11 @@
           </a:p>
           <a:p>
             <a:r>
-              <a:rPr lang="pl-PL" dirty="0"/>
+              <a:rPr lang="pl-PL" dirty="0">
+                <a:highlight>
+                  <a:srgbClr val="00FF00"/>
+                </a:highlight>
+              </a:rPr>
               <a:t>Przycisk przekierowujący do dodania wydatku ręcznie lub z paragonu</a:t>
             </a:r>
           </a:p>

</xml_diff>

<commit_message>
map functionality, theme fixes, location picker from map, adress and place name
</commit_message>
<xml_diff>
--- a/Prezentacja-zalozen.pptx
+++ b/Prezentacja-zalozen.pptx
@@ -3623,8 +3623,24 @@
           </a:p>
           <a:p>
             <a:r>
+              <a:rPr lang="pl-PL" dirty="0">
+                <a:highlight>
+                  <a:srgbClr val="008000"/>
+                </a:highlight>
+              </a:rPr>
+              <a:t>Mapa sklepów </a:t>
+            </a:r>
+            <a:r>
               <a:rPr lang="pl-PL" dirty="0"/>
-              <a:t>Mapa sklepów oraz listy zakupowe – podsumowanie wydatków w danym sklepie.</a:t>
+              <a:t>oraz listy zakupowe – </a:t>
+            </a:r>
+            <a:r>
+              <a:rPr lang="pl-PL" dirty="0">
+                <a:highlight>
+                  <a:srgbClr val="008000"/>
+                </a:highlight>
+              </a:rPr>
+              <a:t>podsumowanie wydatków w danym sklepie.</a:t>
             </a:r>
           </a:p>
         </p:txBody>

</xml_diff>

<commit_message>
shopping lists, savings self, savings family, theme ajustments
</commit_message>
<xml_diff>
--- a/Prezentacja-zalozen.pptx
+++ b/Prezentacja-zalozen.pptx
@@ -3632,7 +3632,19 @@
             </a:r>
             <a:r>
               <a:rPr lang="pl-PL" dirty="0"/>
-              <a:t>oraz listy zakupowe – </a:t>
+              <a:t>oraz </a:t>
+            </a:r>
+            <a:r>
+              <a:rPr lang="pl-PL" dirty="0">
+                <a:highlight>
+                  <a:srgbClr val="008000"/>
+                </a:highlight>
+              </a:rPr>
+              <a:t>listy zakupowe </a:t>
+            </a:r>
+            <a:r>
+              <a:rPr lang="pl-PL" dirty="0"/>
+              <a:t>– </a:t>
             </a:r>
             <a:r>
               <a:rPr lang="pl-PL" dirty="0">
@@ -3745,8 +3757,16 @@
           </a:p>
           <a:p>
             <a:r>
+              <a:rPr lang="pl-PL" dirty="0">
+                <a:highlight>
+                  <a:srgbClr val="008000"/>
+                </a:highlight>
+              </a:rPr>
+              <a:t>Wspólne cele finansowe, oszczędzanie</a:t>
+            </a:r>
+            <a:r>
               <a:rPr lang="pl-PL" dirty="0"/>
-              <a:t>Wspólne cele finansowe, oszczędzanie.</a:t>
+              <a:t>.</a:t>
             </a:r>
           </a:p>
           <a:p>

</xml_diff>